<commit_message>
Update docs to reflect cloud deployment and pattern fidelity fix
- Report + presentation now note live URL (bioform.vercel.app) and cloud build
- Added Session 12 (Cloud Deployment) and Session 13 (Pattern Fidelity Fix) to report timeline
- Added Phase 7 + Phase 8 to presentation development journey
- Removed Deployment from Remaining Work / Future Roadmap (done)
- Updated backend test count 89 -> 93
- Regenerated BioForm_Presentation.pptx
</commit_message>
<xml_diff>
--- a/docs/BioForm_Presentation.pptx
+++ b/docs/BioForm_Presentation.pptx
@@ -5027,7 +5027,7 @@
               </a:defRPr>
             </a:pPr>
             <a:r>
-              <a:t>•  Ollama (optional) — LLM classification</a:t>
+              <a:t>•  Ollama — optional local LLM (disabled in cloud build)</a:t>
             </a:r>
           </a:p>
         </p:txBody>
@@ -5785,6 +5785,180 @@
           </a:p>
         </p:txBody>
       </p:sp>
+      <p:sp>
+        <p:nvSpPr>
+          <p:cNvPr id="15" name="Rounded Rectangle 14"/>
+          <p:cNvSpPr/>
+          <p:nvPr/>
+        </p:nvSpPr>
+        <p:spPr>
+          <a:xfrm>
+            <a:off x="731520" y="6217920"/>
+            <a:ext cx="1645920" cy="502920"/>
+          </a:xfrm>
+          <a:prstGeom prst="roundRect">
+            <a:avLst/>
+          </a:prstGeom>
+          <a:solidFill>
+            <a:srgbClr val="2D5038"/>
+          </a:solidFill>
+          <a:ln>
+            <a:noFill/>
+          </a:ln>
+        </p:spPr>
+        <p:style>
+          <a:lnRef idx="1">
+            <a:schemeClr val="accent1"/>
+          </a:lnRef>
+          <a:fillRef idx="3">
+            <a:schemeClr val="accent1"/>
+          </a:fillRef>
+          <a:effectRef idx="2">
+            <a:schemeClr val="accent1"/>
+          </a:effectRef>
+          <a:fontRef idx="minor">
+            <a:schemeClr val="lt1"/>
+          </a:fontRef>
+        </p:style>
+        <p:txBody>
+          <a:bodyPr rtlCol="0" anchor="ctr"/>
+          <a:lstStyle/>
+          <a:p>
+            <a:pPr algn="ctr">
+              <a:defRPr sz="1400" b="1">
+                <a:solidFill>
+                  <a:srgbClr val="F5F5F0"/>
+                </a:solidFill>
+                <a:latin typeface="Century Gothic"/>
+              </a:defRPr>
+            </a:pPr>
+            <a:r>
+              <a:t>Phase 7</a:t>
+            </a:r>
+          </a:p>
+        </p:txBody>
+      </p:sp>
+      <p:sp>
+        <p:nvSpPr>
+          <p:cNvPr id="16" name="TextBox 15"/>
+          <p:cNvSpPr txBox="1"/>
+          <p:nvPr/>
+        </p:nvSpPr>
+        <p:spPr>
+          <a:xfrm>
+            <a:off x="2743200" y="6217920"/>
+            <a:ext cx="8229600" cy="502920"/>
+          </a:xfrm>
+          <a:prstGeom prst="rect">
+            <a:avLst/>
+          </a:prstGeom>
+          <a:noFill/>
+        </p:spPr>
+        <p:txBody>
+          <a:bodyPr wrap="square"/>
+          <a:lstStyle/>
+          <a:p>
+            <a:pPr algn="l">
+              <a:defRPr sz="1600" b="0">
+                <a:solidFill>
+                  <a:srgbClr val="F5F5F0"/>
+                </a:solidFill>
+                <a:latin typeface="Calibri Light"/>
+              </a:defRPr>
+            </a:pPr>
+            <a:r>
+              <a:t>Cloud deployment — Vercel + Render on free tiers, guarded upload flow</a:t>
+            </a:r>
+          </a:p>
+        </p:txBody>
+      </p:sp>
+      <p:sp>
+        <p:nvSpPr>
+          <p:cNvPr id="17" name="Rounded Rectangle 16"/>
+          <p:cNvSpPr/>
+          <p:nvPr/>
+        </p:nvSpPr>
+        <p:spPr>
+          <a:xfrm>
+            <a:off x="731520" y="6995160"/>
+            <a:ext cx="1645920" cy="502920"/>
+          </a:xfrm>
+          <a:prstGeom prst="roundRect">
+            <a:avLst/>
+          </a:prstGeom>
+          <a:solidFill>
+            <a:srgbClr val="2D5038"/>
+          </a:solidFill>
+          <a:ln>
+            <a:noFill/>
+          </a:ln>
+        </p:spPr>
+        <p:style>
+          <a:lnRef idx="1">
+            <a:schemeClr val="accent1"/>
+          </a:lnRef>
+          <a:fillRef idx="3">
+            <a:schemeClr val="accent1"/>
+          </a:fillRef>
+          <a:effectRef idx="2">
+            <a:schemeClr val="accent1"/>
+          </a:effectRef>
+          <a:fontRef idx="minor">
+            <a:schemeClr val="lt1"/>
+          </a:fontRef>
+        </p:style>
+        <p:txBody>
+          <a:bodyPr rtlCol="0" anchor="ctr"/>
+          <a:lstStyle/>
+          <a:p>
+            <a:pPr algn="ctr">
+              <a:defRPr sz="1400" b="1">
+                <a:solidFill>
+                  <a:srgbClr val="F5F5F0"/>
+                </a:solidFill>
+                <a:latin typeface="Century Gothic"/>
+              </a:defRPr>
+            </a:pPr>
+            <a:r>
+              <a:t>Phase 8</a:t>
+            </a:r>
+          </a:p>
+        </p:txBody>
+      </p:sp>
+      <p:sp>
+        <p:nvSpPr>
+          <p:cNvPr id="18" name="TextBox 17"/>
+          <p:cNvSpPr txBox="1"/>
+          <p:nvPr/>
+        </p:nvSpPr>
+        <p:spPr>
+          <a:xfrm>
+            <a:off x="2743200" y="6995160"/>
+            <a:ext cx="8229600" cy="502920"/>
+          </a:xfrm>
+          <a:prstGeom prst="rect">
+            <a:avLst/>
+          </a:prstGeom>
+          <a:noFill/>
+        </p:spPr>
+        <p:txBody>
+          <a:bodyPr wrap="square"/>
+          <a:lstStyle/>
+          <a:p>
+            <a:pPr algn="l">
+              <a:defRPr sz="1600" b="0">
+                <a:solidFill>
+                  <a:srgbClr val="F5F5F0"/>
+                </a:solidFill>
+                <a:latin typeface="Calibri Light"/>
+              </a:defRPr>
+            </a:pPr>
+            <a:r>
+              <a:t>Pattern fidelity — image-dim normalisation so 3D follows the trace</a:t>
+            </a:r>
+          </a:p>
+        </p:txBody>
+      </p:sp>
     </p:spTree>
   </p:cSld>
   <p:clrMapOvr>
@@ -7145,7 +7319,7 @@
               </a:defRPr>
             </a:pPr>
             <a:r>
-              <a:t>•  Deployment — Vercel (frontend) + Railway/Fly (backend)</a:t>
+              <a:t>•  Additional biomimicry categories (fractal, tessellation)</a:t>
             </a:r>
           </a:p>
           <a:p>
@@ -7161,7 +7335,7 @@
               </a:defRPr>
             </a:pPr>
             <a:r>
-              <a:t>•  Additional biomimicry categories (fractal, tessellation)</a:t>
+              <a:t>•  Multi-building site layouts</a:t>
             </a:r>
           </a:p>
           <a:p>
@@ -7177,7 +7351,7 @@
               </a:defRPr>
             </a:pPr>
             <a:r>
-              <a:t>•  Multi-building site layouts</a:t>
+              <a:t>•  Material and colour mapping from source image</a:t>
             </a:r>
           </a:p>
           <a:p>
@@ -7193,7 +7367,7 @@
               </a:defRPr>
             </a:pPr>
             <a:r>
-              <a:t>•  Material and colour mapping from source image</a:t>
+              <a:t>•  User documentation and onboarding guide</a:t>
             </a:r>
           </a:p>
           <a:p>
@@ -7209,7 +7383,7 @@
               </a:defRPr>
             </a:pPr>
             <a:r>
-              <a:t>•  User documentation and onboarding guide</a:t>
+              <a:t>•  Export to additional formats (IFC, FBX)</a:t>
             </a:r>
           </a:p>
           <a:p>
@@ -7225,7 +7399,7 @@
               </a:defRPr>
             </a:pPr>
             <a:r>
-              <a:t>•  Export to additional formats (IFC, FBX)</a:t>
+              <a:t>•  Paid tier deployment to remove cold-start delay (~40 s) on free Render</a:t>
             </a:r>
           </a:p>
         </p:txBody>
@@ -8218,7 +8392,7 @@
               </a:defRPr>
             </a:pPr>
             <a:r>
-              <a:t>•  Runs locally — no cloud costs, no data leaving the machine</a:t>
+              <a:t>•  Runs locally or free on the web at bioform.vercel.app</a:t>
             </a:r>
           </a:p>
           <a:p>

</xml_diff>